<commit_message>
refining the readme and the pptx
</commit_message>
<xml_diff>
--- a/Alkemy_Business_Presentation_1final1.pptx
+++ b/Alkemy_Business_Presentation_1final1.pptx
@@ -2545,7 +2545,7 @@
                 <a:ea typeface="Arial" pitchFamily="34" charset="-122"/>
                 <a:cs typeface="Arial" pitchFamily="34" charset="-120"/>
               </a:rPr>
-              <a:t>31% → 19% </a:t>
+              <a:t>31.3% → 19.7% </a:t>
             </a:r>
             <a:r>
               <a:rPr lang="en-US" sz="1950" dirty="0">
@@ -2624,7 +2624,7 @@
                 <a:ea typeface="Arial" pitchFamily="34" charset="-122"/>
                 <a:cs typeface="Arial" pitchFamily="34" charset="-120"/>
               </a:rPr>
-              <a:t>THE CRITICAL PIVOT: 50–60%</a:t>
+              <a:t>THE CRITICAL PIVOT: 60–70%</a:t>
             </a:r>
             <a:endParaRPr lang="en-US" sz="2400" dirty="0"/>
           </a:p>
@@ -2668,7 +2668,7 @@
                 <a:ea typeface="Arial" pitchFamily="34" charset="-122"/>
                 <a:cs typeface="Arial" pitchFamily="34" charset="-120"/>
               </a:rPr>
-              <a:t>Between 50–60% AI usage the business crosses from high-loss to </a:t>
+              <a:t>Between 60–70% AI usage the business crosses from high-loss to </a:t>
             </a:r>
             <a:r>
               <a:rPr lang="en-US" sz="1950" dirty="0">
@@ -9444,7 +9444,7 @@
               <a:buNone/>
             </a:pPr>
             <a:r>
-              <a:rPr lang="en-US" sz="3600" b="1" dirty="0">
+              <a:rPr lang="en-US" sz="3600" b="1">
                 <a:solidFill>
                   <a:srgbClr val="E26C00"/>
                 </a:solidFill>
@@ -9452,7 +9452,7 @@
                 <a:ea typeface="Arial" pitchFamily="34" charset="-122"/>
                 <a:cs typeface="Arial" pitchFamily="34" charset="-120"/>
               </a:rPr>
-              <a:t>€242</a:t>
+              <a:t>€235</a:t>
             </a:r>
             <a:endParaRPr lang="en-US" sz="3600" dirty="0"/>
           </a:p>
@@ -11749,7 +11749,7 @@
                 <a:ea typeface="Arial" pitchFamily="34" charset="-122"/>
                 <a:cs typeface="Arial" pitchFamily="34" charset="-120"/>
               </a:rPr>
-              <a:t>€232 in the low band rises to </a:t>
+              <a:t>€233 in the low band rises to </a:t>
             </a:r>
             <a:r>
               <a:rPr lang="en-US" sz="2600" b="1" dirty="0">
@@ -11760,7 +11760,7 @@
                 <a:ea typeface="Arial" pitchFamily="34" charset="-122"/>
                 <a:cs typeface="Arial" pitchFamily="34" charset="-120"/>
               </a:rPr>
-              <a:t>€474 </a:t>
+              <a:t>€468 </a:t>
             </a:r>
             <a:r>
               <a:rPr lang="en-US" sz="1900" dirty="0">
@@ -11960,7 +11960,7 @@
         </p:nvSpPr>
         <p:spPr>
           <a:xfrm>
-            <a:off x="12379234" y="8395567"/>
+            <a:off x="12379232" y="8407328"/>
             <a:ext cx="8044815" cy="444659"/>
           </a:xfrm>
           <a:prstGeom prst="rect">
@@ -12001,18 +12001,7 @@
                 <a:ea typeface="Arial" pitchFamily="34" charset="-122"/>
                 <a:cs typeface="Arial" pitchFamily="34" charset="-120"/>
               </a:rPr>
-              <a:t>31% → 19%</a:t>
-            </a:r>
-            <a:r>
-              <a:rPr lang="en-US" sz="2100" dirty="0">
-                <a:solidFill>
-                  <a:srgbClr val="0D1218"/>
-                </a:solidFill>
-                <a:latin typeface="Arial" pitchFamily="34" charset="0"/>
-                <a:ea typeface="Arial" pitchFamily="34" charset="-122"/>
-                <a:cs typeface="Arial" pitchFamily="34" charset="-120"/>
-              </a:rPr>
-              <a:t>.</a:t>
+              <a:t>31.3% → 19.7%</a:t>
             </a:r>
             <a:endParaRPr lang="en-US" sz="2100" dirty="0"/>
           </a:p>
@@ -12481,7 +12470,7 @@
                 <a:ea typeface="Arial" pitchFamily="34" charset="-122"/>
                 <a:cs typeface="Arial" pitchFamily="34" charset="-120"/>
               </a:rPr>
-              <a:t>1.1 hrs</a:t>
+              <a:t>1.3 hrs</a:t>
             </a:r>
             <a:endParaRPr lang="en-US" sz="9000" dirty="0"/>
           </a:p>
@@ -12525,7 +12514,7 @@
                 <a:ea typeface="Arial" pitchFamily="34" charset="-122"/>
                 <a:cs typeface="Arial" pitchFamily="34" charset="-120"/>
               </a:rPr>
-              <a:t>−2.0 hrs saved + 0.9 hrs rework</a:t>
+              <a:t>−2.0 hrs saved + 0.7 hrs rework</a:t>
             </a:r>
             <a:endParaRPr lang="en-US" sz="2100" dirty="0"/>
           </a:p>
@@ -13460,7 +13449,7 @@
                 <a:ea typeface="Arial" pitchFamily="34" charset="-122"/>
                 <a:cs typeface="Arial" pitchFamily="34" charset="-120"/>
               </a:rPr>
-              <a:t>50–60% threshold. </a:t>
+              <a:t>60–70% threshold. </a:t>
             </a:r>
             <a:r>
               <a:rPr lang="en-US" sz="1950" dirty="0">
@@ -14153,7 +14142,7 @@
                 <a:ea typeface="Arial" pitchFamily="34" charset="-122"/>
                 <a:cs typeface="Arial" pitchFamily="34" charset="-120"/>
               </a:rPr>
-              <a:t>€870 PER-TASK GAP</a:t>
+              <a:t>€872 PER-TASK GAP</a:t>
             </a:r>
             <a:endParaRPr lang="en-US" sz="2700" dirty="0"/>
           </a:p>
@@ -14197,7 +14186,7 @@
                 <a:ea typeface="Arial" pitchFamily="34" charset="-122"/>
                 <a:cs typeface="Arial" pitchFamily="34" charset="-120"/>
               </a:rPr>
-              <a:t>Between Hourly (€202) and Value-based (€1,073) at high AI usage.</a:t>
+              <a:t>Between Hourly (€198) and Value-based (€1,070) at high AI usage.</a:t>
             </a:r>
             <a:endParaRPr lang="en-US" sz="2100" dirty="0"/>
           </a:p>
@@ -17541,7 +17530,7 @@
                 <a:ea typeface="Arial" pitchFamily="34" charset="-122"/>
                 <a:cs typeface="Arial" pitchFamily="34" charset="-120"/>
               </a:rPr>
-              <a:t>50%</a:t>
+              <a:t>51%</a:t>
             </a:r>
             <a:endParaRPr lang="en-US" sz="10500" dirty="0"/>
           </a:p>
@@ -17610,7 +17599,7 @@
         </p:spPr>
         <p:txBody>
           <a:bodyPr wrap="square" lIns="25400" tIns="25400" rIns="25400" bIns="25400" rtlCol="0" anchor="t">
-            <a:normAutofit fontScale="92500"/>
+            <a:normAutofit/>
           </a:bodyPr>
           <a:lstStyle/>
           <a:p>
@@ -17651,7 +17640,7 @@
                 <a:ea typeface="Arial" pitchFamily="34" charset="-122"/>
                 <a:cs typeface="Arial" pitchFamily="34" charset="-120"/>
               </a:rPr>
-              <a:t>at baseline — every unassisted hour compresses margin.</a:t>
+              <a:t>at baseline: every unassisted hour compresses margin.</a:t>
             </a:r>
             <a:endParaRPr lang="en-US" sz="2025" dirty="0"/>
           </a:p>
@@ -17889,7 +17878,7 @@
                 <a:ea typeface="Arial" pitchFamily="34" charset="-122"/>
                 <a:cs typeface="Arial" pitchFamily="34" charset="-120"/>
               </a:rPr>
-              <a:t>MEAN PROFIT PER TASK — ~8× DATASET MEDIAN</a:t>
+              <a:t>MEAN PROFIT PER TASK — ~15× DATASET MEDIAN</a:t>
             </a:r>
             <a:endParaRPr lang="en-US" sz="2100" dirty="0"/>
           </a:p>
@@ -17955,7 +17944,7 @@
                 <a:ea typeface="Arial" pitchFamily="34" charset="-122"/>
                 <a:cs typeface="Arial" pitchFamily="34" charset="-120"/>
               </a:rPr>
-              <a:t>vs −€346 cost drag — net reversal. Observed in 80–100% AI band.</a:t>
+              <a:t>vs −€346 cost drag, net reversal. Observed in 80-100% AI band.</a:t>
             </a:r>
             <a:endParaRPr lang="en-US" sz="2025" dirty="0"/>
           </a:p>

</xml_diff>